<commit_message>
T-0023: Add shape effects API (shadow, glow, reflection, soft edge)
Expand ShadowFormat with shadow_type, angle, blur_radius, distance, and
color properties. Add GlowFormat (radius, color), ReflectionFormat
(blur_radius, distance, direction, start/end opacity), and SoftEdgeFormat
(radius). All effect formats wrap spPr consistently, navigating through
effectLst to their specific child element.

New OXML layer with 6 element classes in oxml/dml/effect.py. Wire glow,
reflection, soft_edge as lazyproperty on BaseShape and GroupShape.
Existing ShadowFormat.inherit behavior preserved unchanged.

Co-Authored-By: Claude Opus 4.6 (1M context) <noreply@anthropic.com>
</commit_message>
<xml_diff>
--- a/features/steps/test_files/dml-effect.pptx
+++ b/features/steps/test_files/dml-effect.pptx
@@ -512,6 +512,48 @@
               <a:t>Inherit == False</a:t>
             </a:r>
             <a:endParaRPr lang="en-US" sz="900" dirty="0"/>
+          </a:p>
+        </p:txBody>
+      </p:sp>
+      <p:sp>
+        <p:nvSpPr>
+          <p:cNvPr id="4" name="Rectangle with Shadow"/>
+          <p:cNvSpPr/>
+          <p:nvPr/>
+        </p:nvSpPr>
+        <p:spPr>
+          <a:xfrm>
+            <a:off x="3657600" y="457200"/>
+            <a:ext cx="1828800" cy="914400"/>
+          </a:xfrm>
+          <a:prstGeom prst="rect">
+            <a:avLst/>
+          </a:prstGeom>
+          <a:effectLst>
+            <a:outerShdw blurRad="40000" dist="23000" dir="5400000">
+              <a:srgbClr val="000000"/>
+            </a:outerShdw>
+          </a:effectLst>
+        </p:spPr>
+        <p:style>
+          <a:lnRef idx="1">
+            <a:schemeClr val="accent1"/>
+          </a:lnRef>
+          <a:fillRef idx="3">
+            <a:schemeClr val="accent1"/>
+          </a:fillRef>
+          <a:effectRef idx="2">
+            <a:schemeClr val="accent1"/>
+          </a:effectRef>
+          <a:fontRef idx="minor">
+            <a:schemeClr val="lt1"/>
+          </a:fontRef>
+        </p:style>
+        <p:txBody>
+          <a:bodyPr rtlCol="0" anchor="ctr"/>
+          <a:lstStyle/>
+          <a:p>
+            <a:pPr algn="ctr"/>
           </a:p>
         </p:txBody>
       </p:sp>

</xml_diff>